<commit_message>
Fix crashes and rendering defects found in generation review
- xlsx: milestone/note landing inside a merged bar no longer crashes
  (write via merge anchor; milestone text is appended to the bar label)
- xlsx: "today" line survives merged bars (openpyxl rewrites merged-range
  borders from the anchor cell on save); skipped honestly when today falls
  inside a bar instead of drawing at the wrong edge
- xlsx: bar borders use line colors so stacked same-style bars don't fuse
- pptx: warn on milestone overlaps; reserve milestone label weeks
- common: warn when bar start/end are reversed instead of silent swap
- sample/schema: MPV->MVP typo, shorten bar label that got truncated,
  document overlap degradation and today-inside-bar limitation
- SKILL.md: sync rows-per-slide with code (15)
- remove stale preview PNGs; rebuild demos, .skill and full.md

Co-Authored-By: Claude Fable 5 <noreply@anthropic.com>
</commit_message>
<xml_diff>
--- a/roadmap_demo.pptx
+++ b/roadmap_demo.pptx
@@ -3184,7 +3184,7 @@
                   <a:srgbClr val="4472C4"/>
                 </a:solidFill>
               </a:rPr>
-              <a:t>MPV — синий</a:t>
+              <a:t>MVP — синий</a:t>
             </a:r>
           </a:p>
         </p:txBody>
@@ -5111,12 +5111,12 @@
           <a:p>
             <a:pPr algn="ctr"/>
             <a:r>
-              <a:rPr sz="850" b="0">
+              <a:rPr sz="750" b="0">
                 <a:solidFill>
                   <a:srgbClr val="333333"/>
                 </a:solidFill>
               </a:rPr>
-              <a:t>Согласование</a:t>
+              <a:t>Согласов.</a:t>
             </a:r>
           </a:p>
         </p:txBody>
@@ -6970,13 +6970,14 @@
           <a:p>
             <a:pPr algn="l"/>
             <a:r>
-              <a:rPr sz="900" b="1">
+              <a:rPr sz="800" b="1">
                 <a:solidFill>
                   <a:srgbClr val="333333"/>
                 </a:solidFill>
               </a:rPr>
               <a:t>КАФО агента (Интеграция, взаимодействие)
-(Д. Шатыр)</a:t>
+(Д. Шатыр)
+Сервисы: CTL, ClickHouse, СберЧат, ЛДБР, IDP</a:t>
             </a:r>
           </a:p>
         </p:txBody>
@@ -7249,7 +7250,8 @@
                 </a:solidFill>
               </a:rPr>
               <a:t>Интеграция
-(С. Славский ?)</a:t>
+(С. Славский ?)
+Сервисы: CTL, СберЧат, ClickHouse</a:t>
             </a:r>
           </a:p>
         </p:txBody>
@@ -7291,14 +7293,60 @@
       </p:cxnSp>
       <p:sp>
         <p:nvSpPr>
-          <p:cNvPr id="93" name="Rectangle 92"/>
-          <p:cNvSpPr/>
-          <p:nvPr/>
-        </p:nvSpPr>
-        <p:spPr>
-          <a:xfrm>
-            <a:off x="228600" y="5934456"/>
-            <a:ext cx="1371600" cy="201168"/>
+          <p:cNvPr id="93" name="Diamond 92"/>
+          <p:cNvSpPr/>
+          <p:nvPr/>
+        </p:nvSpPr>
+        <p:spPr>
+          <a:xfrm>
+            <a:off x="228600" y="5975604"/>
+            <a:ext cx="118872" cy="118872"/>
+          </a:xfrm>
+          <a:prstGeom prst="diamond">
+            <a:avLst/>
+          </a:prstGeom>
+          <a:solidFill>
+            <a:srgbClr val="4CAF50"/>
+          </a:solidFill>
+          <a:ln w="12700">
+            <a:solidFill>
+              <a:srgbClr val="2E7D32"/>
+            </a:solidFill>
+          </a:ln>
+          <a:effectLst/>
+        </p:spPr>
+        <p:style>
+          <a:lnRef idx="1">
+            <a:schemeClr val="accent1"/>
+          </a:lnRef>
+          <a:fillRef idx="3">
+            <a:schemeClr val="accent1"/>
+          </a:fillRef>
+          <a:effectRef idx="2">
+            <a:schemeClr val="accent1"/>
+          </a:effectRef>
+          <a:fontRef idx="minor">
+            <a:schemeClr val="lt1"/>
+          </a:fontRef>
+        </p:style>
+        <p:txBody>
+          <a:bodyPr rtlCol="0" anchor="ctr" wrap="square" lIns="18000" rIns="18000" tIns="9000" bIns="9000"/>
+          <a:lstStyle/>
+          <a:p>
+            <a:pPr algn="ctr"/>
+          </a:p>
+        </p:txBody>
+      </p:sp>
+      <p:sp>
+        <p:nvSpPr>
+          <p:cNvPr id="94" name="Rectangle 93"/>
+          <p:cNvSpPr/>
+          <p:nvPr/>
+        </p:nvSpPr>
+        <p:spPr>
+          <a:xfrm>
+            <a:off x="384048" y="5934456"/>
+            <a:ext cx="1005840" cy="201168"/>
           </a:xfrm>
           <a:prstGeom prst="rect">
             <a:avLst/>
@@ -7331,24 +7379,70 @@
             <a:r>
               <a:rPr sz="800" b="0">
                 <a:solidFill>
-                  <a:srgbClr val="4CAF50"/>
+                  <a:srgbClr val="333333"/>
                 </a:solidFill>
               </a:rPr>
-              <a:t>◆ выполнено</a:t>
-            </a:r>
-          </a:p>
-        </p:txBody>
-      </p:sp>
-      <p:sp>
-        <p:nvSpPr>
-          <p:cNvPr id="94" name="Rectangle 93"/>
+              <a:t>выполнено</a:t>
+            </a:r>
+          </a:p>
+        </p:txBody>
+      </p:sp>
+      <p:sp>
+        <p:nvSpPr>
+          <p:cNvPr id="95" name="Diamond 94"/>
+          <p:cNvSpPr/>
+          <p:nvPr/>
+        </p:nvSpPr>
+        <p:spPr>
+          <a:xfrm>
+            <a:off x="1490472" y="5975604"/>
+            <a:ext cx="118872" cy="118872"/>
+          </a:xfrm>
+          <a:prstGeom prst="diamond">
+            <a:avLst/>
+          </a:prstGeom>
+          <a:solidFill>
+            <a:srgbClr val="FFFFFF"/>
+          </a:solidFill>
+          <a:ln w="12700">
+            <a:solidFill>
+              <a:srgbClr val="E53935"/>
+            </a:solidFill>
+          </a:ln>
+          <a:effectLst/>
+        </p:spPr>
+        <p:style>
+          <a:lnRef idx="1">
+            <a:schemeClr val="accent1"/>
+          </a:lnRef>
+          <a:fillRef idx="3">
+            <a:schemeClr val="accent1"/>
+          </a:fillRef>
+          <a:effectRef idx="2">
+            <a:schemeClr val="accent1"/>
+          </a:effectRef>
+          <a:fontRef idx="minor">
+            <a:schemeClr val="lt1"/>
+          </a:fontRef>
+        </p:style>
+        <p:txBody>
+          <a:bodyPr rtlCol="0" anchor="ctr" wrap="square" lIns="18000" rIns="18000" tIns="9000" bIns="9000"/>
+          <a:lstStyle/>
+          <a:p>
+            <a:pPr algn="ctr"/>
+          </a:p>
+        </p:txBody>
+      </p:sp>
+      <p:sp>
+        <p:nvSpPr>
+          <p:cNvPr id="96" name="Rectangle 95"/>
           <p:cNvSpPr/>
           <p:nvPr/>
         </p:nvSpPr>
         <p:spPr>
           <a:xfrm>
             <a:off x="1645920" y="5934456"/>
-            <a:ext cx="1371600" cy="201168"/>
+            <a:ext cx="1005840" cy="201168"/>
           </a:xfrm>
           <a:prstGeom prst="rect">
             <a:avLst/>
@@ -7381,24 +7475,70 @@
             <a:r>
               <a:rPr sz="800" b="0">
                 <a:solidFill>
-                  <a:srgbClr val="E53935"/>
+                  <a:srgbClr val="333333"/>
                 </a:solidFill>
               </a:rPr>
-              <a:t>◇ план</a:t>
-            </a:r>
-          </a:p>
-        </p:txBody>
-      </p:sp>
-      <p:sp>
-        <p:nvSpPr>
-          <p:cNvPr id="95" name="Rectangle 94"/>
+              <a:t>план</a:t>
+            </a:r>
+          </a:p>
+        </p:txBody>
+      </p:sp>
+      <p:sp>
+        <p:nvSpPr>
+          <p:cNvPr id="97" name="Rounded Rectangle 96"/>
+          <p:cNvSpPr/>
+          <p:nvPr/>
+        </p:nvSpPr>
+        <p:spPr>
+          <a:xfrm>
+            <a:off x="2752344" y="5975604"/>
+            <a:ext cx="274320" cy="118872"/>
+          </a:xfrm>
+          <a:prstGeom prst="roundRect">
+            <a:avLst/>
+          </a:prstGeom>
+          <a:solidFill>
+            <a:srgbClr val="F5A623"/>
+          </a:solidFill>
+          <a:ln w="12700">
+            <a:solidFill>
+              <a:srgbClr val="C77F00"/>
+            </a:solidFill>
+          </a:ln>
+          <a:effectLst/>
+        </p:spPr>
+        <p:style>
+          <a:lnRef idx="1">
+            <a:schemeClr val="accent1"/>
+          </a:lnRef>
+          <a:fillRef idx="3">
+            <a:schemeClr val="accent1"/>
+          </a:fillRef>
+          <a:effectRef idx="2">
+            <a:schemeClr val="accent1"/>
+          </a:effectRef>
+          <a:fontRef idx="minor">
+            <a:schemeClr val="lt1"/>
+          </a:fontRef>
+        </p:style>
+        <p:txBody>
+          <a:bodyPr rtlCol="0" anchor="ctr" wrap="square" lIns="18000" rIns="18000" tIns="9000" bIns="9000"/>
+          <a:lstStyle/>
+          <a:p>
+            <a:pPr algn="ctr"/>
+          </a:p>
+        </p:txBody>
+      </p:sp>
+      <p:sp>
+        <p:nvSpPr>
+          <p:cNvPr id="98" name="Rectangle 97"/>
           <p:cNvSpPr/>
           <p:nvPr/>
         </p:nvSpPr>
         <p:spPr>
           <a:xfrm>
             <a:off x="3063240" y="5934456"/>
-            <a:ext cx="1371600" cy="201168"/>
+            <a:ext cx="1005840" cy="201168"/>
           </a:xfrm>
           <a:prstGeom prst="rect">
             <a:avLst/>
@@ -7431,24 +7571,70 @@
             <a:r>
               <a:rPr sz="800" b="0">
                 <a:solidFill>
-                  <a:srgbClr val="F5A623"/>
+                  <a:srgbClr val="333333"/>
                 </a:solidFill>
               </a:rPr>
-              <a:t>▬ работы</a:t>
-            </a:r>
-          </a:p>
-        </p:txBody>
-      </p:sp>
-      <p:sp>
-        <p:nvSpPr>
-          <p:cNvPr id="96" name="Rectangle 95"/>
+              <a:t>работы</a:t>
+            </a:r>
+          </a:p>
+        </p:txBody>
+      </p:sp>
+      <p:sp>
+        <p:nvSpPr>
+          <p:cNvPr id="99" name="Rounded Rectangle 98"/>
+          <p:cNvSpPr/>
+          <p:nvPr/>
+        </p:nvSpPr>
+        <p:spPr>
+          <a:xfrm>
+            <a:off x="4169664" y="5975604"/>
+            <a:ext cx="274320" cy="118872"/>
+          </a:xfrm>
+          <a:prstGeom prst="roundRect">
+            <a:avLst/>
+          </a:prstGeom>
+          <a:solidFill>
+            <a:srgbClr val="FBEAB6"/>
+          </a:solidFill>
+          <a:ln w="12700">
+            <a:solidFill>
+              <a:srgbClr val="E0C878"/>
+            </a:solidFill>
+          </a:ln>
+          <a:effectLst/>
+        </p:spPr>
+        <p:style>
+          <a:lnRef idx="1">
+            <a:schemeClr val="accent1"/>
+          </a:lnRef>
+          <a:fillRef idx="3">
+            <a:schemeClr val="accent1"/>
+          </a:fillRef>
+          <a:effectRef idx="2">
+            <a:schemeClr val="accent1"/>
+          </a:effectRef>
+          <a:fontRef idx="minor">
+            <a:schemeClr val="lt1"/>
+          </a:fontRef>
+        </p:style>
+        <p:txBody>
+          <a:bodyPr rtlCol="0" anchor="ctr" wrap="square" lIns="18000" rIns="18000" tIns="9000" bIns="9000"/>
+          <a:lstStyle/>
+          <a:p>
+            <a:pPr algn="ctr"/>
+          </a:p>
+        </p:txBody>
+      </p:sp>
+      <p:sp>
+        <p:nvSpPr>
+          <p:cNvPr id="100" name="Rectangle 99"/>
           <p:cNvSpPr/>
           <p:nvPr/>
         </p:nvSpPr>
         <p:spPr>
           <a:xfrm>
             <a:off x="4480560" y="5934456"/>
-            <a:ext cx="1371600" cy="201168"/>
+            <a:ext cx="1005840" cy="201168"/>
           </a:xfrm>
           <a:prstGeom prst="rect">
             <a:avLst/>
@@ -7481,24 +7667,70 @@
             <a:r>
               <a:rPr sz="800" b="0">
                 <a:solidFill>
-                  <a:srgbClr val="FBEAB6"/>
+                  <a:srgbClr val="333333"/>
                 </a:solidFill>
               </a:rPr>
-              <a:t>▬ оценка т/з</a:t>
-            </a:r>
-          </a:p>
-        </p:txBody>
-      </p:sp>
-      <p:sp>
-        <p:nvSpPr>
-          <p:cNvPr id="97" name="Rectangle 96"/>
+              <a:t>оценка т/з</a:t>
+            </a:r>
+          </a:p>
+        </p:txBody>
+      </p:sp>
+      <p:sp>
+        <p:nvSpPr>
+          <p:cNvPr id="101" name="Rounded Rectangle 100"/>
+          <p:cNvSpPr/>
+          <p:nvPr/>
+        </p:nvSpPr>
+        <p:spPr>
+          <a:xfrm>
+            <a:off x="5586984" y="5975604"/>
+            <a:ext cx="274320" cy="118872"/>
+          </a:xfrm>
+          <a:prstGeom prst="roundRect">
+            <a:avLst/>
+          </a:prstGeom>
+          <a:solidFill>
+            <a:srgbClr val="FFF176"/>
+          </a:solidFill>
+          <a:ln w="12700">
+            <a:solidFill>
+              <a:srgbClr val="D4C24A"/>
+            </a:solidFill>
+          </a:ln>
+          <a:effectLst/>
+        </p:spPr>
+        <p:style>
+          <a:lnRef idx="1">
+            <a:schemeClr val="accent1"/>
+          </a:lnRef>
+          <a:fillRef idx="3">
+            <a:schemeClr val="accent1"/>
+          </a:fillRef>
+          <a:effectRef idx="2">
+            <a:schemeClr val="accent1"/>
+          </a:effectRef>
+          <a:fontRef idx="minor">
+            <a:schemeClr val="lt1"/>
+          </a:fontRef>
+        </p:style>
+        <p:txBody>
+          <a:bodyPr rtlCol="0" anchor="ctr" wrap="square" lIns="18000" rIns="18000" tIns="9000" bIns="9000"/>
+          <a:lstStyle/>
+          <a:p>
+            <a:pPr algn="ctr"/>
+          </a:p>
+        </p:txBody>
+      </p:sp>
+      <p:sp>
+        <p:nvSpPr>
+          <p:cNvPr id="102" name="Rectangle 101"/>
           <p:cNvSpPr/>
           <p:nvPr/>
         </p:nvSpPr>
         <p:spPr>
           <a:xfrm>
             <a:off x="5897880" y="5934456"/>
-            <a:ext cx="1371600" cy="201168"/>
+            <a:ext cx="1005840" cy="201168"/>
           </a:xfrm>
           <a:prstGeom prst="rect">
             <a:avLst/>
@@ -7531,10 +7763,10 @@
             <a:r>
               <a:rPr sz="800" b="0">
                 <a:solidFill>
-                  <a:srgbClr val="FFF176"/>
+                  <a:srgbClr val="333333"/>
                 </a:solidFill>
               </a:rPr>
-              <a:t>▬ отпуск</a:t>
+              <a:t>отпуск</a:t>
             </a:r>
           </a:p>
         </p:txBody>
@@ -7652,7 +7884,7 @@
                   <a:srgbClr val="4472C4"/>
                 </a:solidFill>
               </a:rPr>
-              <a:t>MPV — синий</a:t>
+              <a:t>MVP — синий</a:t>
             </a:r>
           </a:p>
         </p:txBody>
@@ -9609,7 +9841,8 @@
                 </a:solidFill>
               </a:rPr>
               <a:t>Интеграция с IDP (RAG)
-(С. Славский ?)</a:t>
+(С. Славский ?)
+Сервисы: IDP</a:t>
             </a:r>
           </a:p>
         </p:txBody>
@@ -9651,14 +9884,60 @@
       </p:cxnSp>
       <p:sp>
         <p:nvSpPr>
-          <p:cNvPr id="48" name="Rectangle 47"/>
-          <p:cNvSpPr/>
-          <p:nvPr/>
-        </p:nvSpPr>
-        <p:spPr>
-          <a:xfrm>
-            <a:off x="228600" y="2514600"/>
-            <a:ext cx="1371600" cy="201168"/>
+          <p:cNvPr id="48" name="Diamond 47"/>
+          <p:cNvSpPr/>
+          <p:nvPr/>
+        </p:nvSpPr>
+        <p:spPr>
+          <a:xfrm>
+            <a:off x="228600" y="2555748"/>
+            <a:ext cx="118872" cy="118872"/>
+          </a:xfrm>
+          <a:prstGeom prst="diamond">
+            <a:avLst/>
+          </a:prstGeom>
+          <a:solidFill>
+            <a:srgbClr val="4CAF50"/>
+          </a:solidFill>
+          <a:ln w="12700">
+            <a:solidFill>
+              <a:srgbClr val="2E7D32"/>
+            </a:solidFill>
+          </a:ln>
+          <a:effectLst/>
+        </p:spPr>
+        <p:style>
+          <a:lnRef idx="1">
+            <a:schemeClr val="accent1"/>
+          </a:lnRef>
+          <a:fillRef idx="3">
+            <a:schemeClr val="accent1"/>
+          </a:fillRef>
+          <a:effectRef idx="2">
+            <a:schemeClr val="accent1"/>
+          </a:effectRef>
+          <a:fontRef idx="minor">
+            <a:schemeClr val="lt1"/>
+          </a:fontRef>
+        </p:style>
+        <p:txBody>
+          <a:bodyPr rtlCol="0" anchor="ctr" wrap="square" lIns="18000" rIns="18000" tIns="9000" bIns="9000"/>
+          <a:lstStyle/>
+          <a:p>
+            <a:pPr algn="ctr"/>
+          </a:p>
+        </p:txBody>
+      </p:sp>
+      <p:sp>
+        <p:nvSpPr>
+          <p:cNvPr id="49" name="Rectangle 48"/>
+          <p:cNvSpPr/>
+          <p:nvPr/>
+        </p:nvSpPr>
+        <p:spPr>
+          <a:xfrm>
+            <a:off x="384048" y="2514600"/>
+            <a:ext cx="1005840" cy="201168"/>
           </a:xfrm>
           <a:prstGeom prst="rect">
             <a:avLst/>
@@ -9691,24 +9970,70 @@
             <a:r>
               <a:rPr sz="800" b="0">
                 <a:solidFill>
-                  <a:srgbClr val="4CAF50"/>
+                  <a:srgbClr val="333333"/>
                 </a:solidFill>
               </a:rPr>
-              <a:t>◆ выполнено</a:t>
-            </a:r>
-          </a:p>
-        </p:txBody>
-      </p:sp>
-      <p:sp>
-        <p:nvSpPr>
-          <p:cNvPr id="49" name="Rectangle 48"/>
+              <a:t>выполнено</a:t>
+            </a:r>
+          </a:p>
+        </p:txBody>
+      </p:sp>
+      <p:sp>
+        <p:nvSpPr>
+          <p:cNvPr id="50" name="Diamond 49"/>
+          <p:cNvSpPr/>
+          <p:nvPr/>
+        </p:nvSpPr>
+        <p:spPr>
+          <a:xfrm>
+            <a:off x="1490472" y="2555748"/>
+            <a:ext cx="118872" cy="118872"/>
+          </a:xfrm>
+          <a:prstGeom prst="diamond">
+            <a:avLst/>
+          </a:prstGeom>
+          <a:solidFill>
+            <a:srgbClr val="FFFFFF"/>
+          </a:solidFill>
+          <a:ln w="12700">
+            <a:solidFill>
+              <a:srgbClr val="E53935"/>
+            </a:solidFill>
+          </a:ln>
+          <a:effectLst/>
+        </p:spPr>
+        <p:style>
+          <a:lnRef idx="1">
+            <a:schemeClr val="accent1"/>
+          </a:lnRef>
+          <a:fillRef idx="3">
+            <a:schemeClr val="accent1"/>
+          </a:fillRef>
+          <a:effectRef idx="2">
+            <a:schemeClr val="accent1"/>
+          </a:effectRef>
+          <a:fontRef idx="minor">
+            <a:schemeClr val="lt1"/>
+          </a:fontRef>
+        </p:style>
+        <p:txBody>
+          <a:bodyPr rtlCol="0" anchor="ctr" wrap="square" lIns="18000" rIns="18000" tIns="9000" bIns="9000"/>
+          <a:lstStyle/>
+          <a:p>
+            <a:pPr algn="ctr"/>
+          </a:p>
+        </p:txBody>
+      </p:sp>
+      <p:sp>
+        <p:nvSpPr>
+          <p:cNvPr id="51" name="Rectangle 50"/>
           <p:cNvSpPr/>
           <p:nvPr/>
         </p:nvSpPr>
         <p:spPr>
           <a:xfrm>
             <a:off x="1645920" y="2514600"/>
-            <a:ext cx="1371600" cy="201168"/>
+            <a:ext cx="1005840" cy="201168"/>
           </a:xfrm>
           <a:prstGeom prst="rect">
             <a:avLst/>
@@ -9741,24 +10066,70 @@
             <a:r>
               <a:rPr sz="800" b="0">
                 <a:solidFill>
-                  <a:srgbClr val="E53935"/>
+                  <a:srgbClr val="333333"/>
                 </a:solidFill>
               </a:rPr>
-              <a:t>◇ план</a:t>
-            </a:r>
-          </a:p>
-        </p:txBody>
-      </p:sp>
-      <p:sp>
-        <p:nvSpPr>
-          <p:cNvPr id="50" name="Rectangle 49"/>
+              <a:t>план</a:t>
+            </a:r>
+          </a:p>
+        </p:txBody>
+      </p:sp>
+      <p:sp>
+        <p:nvSpPr>
+          <p:cNvPr id="52" name="Rounded Rectangle 51"/>
+          <p:cNvSpPr/>
+          <p:nvPr/>
+        </p:nvSpPr>
+        <p:spPr>
+          <a:xfrm>
+            <a:off x="2752344" y="2555748"/>
+            <a:ext cx="274320" cy="118872"/>
+          </a:xfrm>
+          <a:prstGeom prst="roundRect">
+            <a:avLst/>
+          </a:prstGeom>
+          <a:solidFill>
+            <a:srgbClr val="F5A623"/>
+          </a:solidFill>
+          <a:ln w="12700">
+            <a:solidFill>
+              <a:srgbClr val="C77F00"/>
+            </a:solidFill>
+          </a:ln>
+          <a:effectLst/>
+        </p:spPr>
+        <p:style>
+          <a:lnRef idx="1">
+            <a:schemeClr val="accent1"/>
+          </a:lnRef>
+          <a:fillRef idx="3">
+            <a:schemeClr val="accent1"/>
+          </a:fillRef>
+          <a:effectRef idx="2">
+            <a:schemeClr val="accent1"/>
+          </a:effectRef>
+          <a:fontRef idx="minor">
+            <a:schemeClr val="lt1"/>
+          </a:fontRef>
+        </p:style>
+        <p:txBody>
+          <a:bodyPr rtlCol="0" anchor="ctr" wrap="square" lIns="18000" rIns="18000" tIns="9000" bIns="9000"/>
+          <a:lstStyle/>
+          <a:p>
+            <a:pPr algn="ctr"/>
+          </a:p>
+        </p:txBody>
+      </p:sp>
+      <p:sp>
+        <p:nvSpPr>
+          <p:cNvPr id="53" name="Rectangle 52"/>
           <p:cNvSpPr/>
           <p:nvPr/>
         </p:nvSpPr>
         <p:spPr>
           <a:xfrm>
             <a:off x="3063240" y="2514600"/>
-            <a:ext cx="1371600" cy="201168"/>
+            <a:ext cx="1005840" cy="201168"/>
           </a:xfrm>
           <a:prstGeom prst="rect">
             <a:avLst/>
@@ -9791,24 +10162,70 @@
             <a:r>
               <a:rPr sz="800" b="0">
                 <a:solidFill>
-                  <a:srgbClr val="F5A623"/>
+                  <a:srgbClr val="333333"/>
                 </a:solidFill>
               </a:rPr>
-              <a:t>▬ работы</a:t>
-            </a:r>
-          </a:p>
-        </p:txBody>
-      </p:sp>
-      <p:sp>
-        <p:nvSpPr>
-          <p:cNvPr id="51" name="Rectangle 50"/>
+              <a:t>работы</a:t>
+            </a:r>
+          </a:p>
+        </p:txBody>
+      </p:sp>
+      <p:sp>
+        <p:nvSpPr>
+          <p:cNvPr id="54" name="Rounded Rectangle 53"/>
+          <p:cNvSpPr/>
+          <p:nvPr/>
+        </p:nvSpPr>
+        <p:spPr>
+          <a:xfrm>
+            <a:off x="4169664" y="2555748"/>
+            <a:ext cx="274320" cy="118872"/>
+          </a:xfrm>
+          <a:prstGeom prst="roundRect">
+            <a:avLst/>
+          </a:prstGeom>
+          <a:solidFill>
+            <a:srgbClr val="FBEAB6"/>
+          </a:solidFill>
+          <a:ln w="12700">
+            <a:solidFill>
+              <a:srgbClr val="E0C878"/>
+            </a:solidFill>
+          </a:ln>
+          <a:effectLst/>
+        </p:spPr>
+        <p:style>
+          <a:lnRef idx="1">
+            <a:schemeClr val="accent1"/>
+          </a:lnRef>
+          <a:fillRef idx="3">
+            <a:schemeClr val="accent1"/>
+          </a:fillRef>
+          <a:effectRef idx="2">
+            <a:schemeClr val="accent1"/>
+          </a:effectRef>
+          <a:fontRef idx="minor">
+            <a:schemeClr val="lt1"/>
+          </a:fontRef>
+        </p:style>
+        <p:txBody>
+          <a:bodyPr rtlCol="0" anchor="ctr" wrap="square" lIns="18000" rIns="18000" tIns="9000" bIns="9000"/>
+          <a:lstStyle/>
+          <a:p>
+            <a:pPr algn="ctr"/>
+          </a:p>
+        </p:txBody>
+      </p:sp>
+      <p:sp>
+        <p:nvSpPr>
+          <p:cNvPr id="55" name="Rectangle 54"/>
           <p:cNvSpPr/>
           <p:nvPr/>
         </p:nvSpPr>
         <p:spPr>
           <a:xfrm>
             <a:off x="4480560" y="2514600"/>
-            <a:ext cx="1371600" cy="201168"/>
+            <a:ext cx="1005840" cy="201168"/>
           </a:xfrm>
           <a:prstGeom prst="rect">
             <a:avLst/>
@@ -9841,24 +10258,70 @@
             <a:r>
               <a:rPr sz="800" b="0">
                 <a:solidFill>
-                  <a:srgbClr val="FBEAB6"/>
+                  <a:srgbClr val="333333"/>
                 </a:solidFill>
               </a:rPr>
-              <a:t>▬ оценка т/з</a:t>
-            </a:r>
-          </a:p>
-        </p:txBody>
-      </p:sp>
-      <p:sp>
-        <p:nvSpPr>
-          <p:cNvPr id="52" name="Rectangle 51"/>
+              <a:t>оценка т/з</a:t>
+            </a:r>
+          </a:p>
+        </p:txBody>
+      </p:sp>
+      <p:sp>
+        <p:nvSpPr>
+          <p:cNvPr id="56" name="Rounded Rectangle 55"/>
+          <p:cNvSpPr/>
+          <p:nvPr/>
+        </p:nvSpPr>
+        <p:spPr>
+          <a:xfrm>
+            <a:off x="5586984" y="2555748"/>
+            <a:ext cx="274320" cy="118872"/>
+          </a:xfrm>
+          <a:prstGeom prst="roundRect">
+            <a:avLst/>
+          </a:prstGeom>
+          <a:solidFill>
+            <a:srgbClr val="FFF176"/>
+          </a:solidFill>
+          <a:ln w="12700">
+            <a:solidFill>
+              <a:srgbClr val="D4C24A"/>
+            </a:solidFill>
+          </a:ln>
+          <a:effectLst/>
+        </p:spPr>
+        <p:style>
+          <a:lnRef idx="1">
+            <a:schemeClr val="accent1"/>
+          </a:lnRef>
+          <a:fillRef idx="3">
+            <a:schemeClr val="accent1"/>
+          </a:fillRef>
+          <a:effectRef idx="2">
+            <a:schemeClr val="accent1"/>
+          </a:effectRef>
+          <a:fontRef idx="minor">
+            <a:schemeClr val="lt1"/>
+          </a:fontRef>
+        </p:style>
+        <p:txBody>
+          <a:bodyPr rtlCol="0" anchor="ctr" wrap="square" lIns="18000" rIns="18000" tIns="9000" bIns="9000"/>
+          <a:lstStyle/>
+          <a:p>
+            <a:pPr algn="ctr"/>
+          </a:p>
+        </p:txBody>
+      </p:sp>
+      <p:sp>
+        <p:nvSpPr>
+          <p:cNvPr id="57" name="Rectangle 56"/>
           <p:cNvSpPr/>
           <p:nvPr/>
         </p:nvSpPr>
         <p:spPr>
           <a:xfrm>
             <a:off x="5897880" y="2514600"/>
-            <a:ext cx="1371600" cy="201168"/>
+            <a:ext cx="1005840" cy="201168"/>
           </a:xfrm>
           <a:prstGeom prst="rect">
             <a:avLst/>
@@ -9891,10 +10354,10 @@
             <a:r>
               <a:rPr sz="800" b="0">
                 <a:solidFill>
-                  <a:srgbClr val="FFF176"/>
+                  <a:srgbClr val="333333"/>
                 </a:solidFill>
               </a:rPr>
-              <a:t>▬ отпуск</a:t>
+              <a:t>отпуск</a:t>
             </a:r>
           </a:p>
         </p:txBody>

</xml_diff>